<commit_message>
Drop team roles from the submission deck and docs index
- Team Details slide: keep team name and leader as the template asks; remove member photos and roles
- Remove the team / work-division line from the closing slide and its role list from the speaker note
- docs index: remove the team roles table
</commit_message>
<xml_diff>
--- a/docs/pitch-deck/Property_Inspection_AI_Submission_Xcore.pptx
+++ b/docs/pitch-deck/Property_Inspection_AI_Submission_Xcore.pptx
@@ -415,7 +415,7 @@
               </c14:invertSolidFillFmt>
             </c:ext>
             <c:ext xmlns:c16="http://schemas.microsoft.com/office/drawing/2014/chart" uri="{C3380CC4-5D6E-409C-BE32-E72D297353CC}">
-              <c16:uniqueId val="{00000000-2E72-497C-B236-139A3702FA19}"/>
+              <c16:uniqueId val="{00000000-9DBF-47BF-85E2-FE095F3FB268}"/>
             </c:ext>
           </c:extLst>
         </c:ser>
@@ -529,7 +529,7 @@
               </c14:invertSolidFillFmt>
             </c:ext>
             <c:ext xmlns:c16="http://schemas.microsoft.com/office/drawing/2014/chart" uri="{C3380CC4-5D6E-409C-BE32-E72D297353CC}">
-              <c16:uniqueId val="{00000001-2E72-497C-B236-139A3702FA19}"/>
+              <c16:uniqueId val="{00000001-9DBF-47BF-85E2-FE095F3FB268}"/>
             </c:ext>
           </c:extLst>
         </c:ser>
@@ -643,7 +643,7 @@
               </c14:invertSolidFillFmt>
             </c:ext>
             <c:ext xmlns:c16="http://schemas.microsoft.com/office/drawing/2014/chart" uri="{C3380CC4-5D6E-409C-BE32-E72D297353CC}">
-              <c16:uniqueId val="{00000002-2E72-497C-B236-139A3702FA19}"/>
+              <c16:uniqueId val="{00000002-9DBF-47BF-85E2-FE095F3FB268}"/>
             </c:ext>
           </c:extLst>
         </c:ser>
@@ -757,7 +757,7 @@
               </c14:invertSolidFillFmt>
             </c:ext>
             <c:ext xmlns:c16="http://schemas.microsoft.com/office/drawing/2014/chart" uri="{C3380CC4-5D6E-409C-BE32-E72D297353CC}">
-              <c16:uniqueId val="{00000003-2E72-497C-B236-139A3702FA19}"/>
+              <c16:uniqueId val="{00000003-9DBF-47BF-85E2-FE095F3FB268}"/>
             </c:ext>
           </c:extLst>
         </c:ser>
@@ -1425,7 +1425,7 @@
           <a:lstStyle/>
           <a:p>
             <a:r>
-              <a:t>Team Xcore, led by Thanveer Ahamed (Gen AI Lead), with Janitha Prathapa (Vision AI Lead) and Dinal Fernando (Solution Architect). BFSI track: Intelligent Risk, Fraud &amp; Financial Experiences.</a:t>
+              <a:t>Team Xcore, led by Thanveer Ahamed. BFSI track: Intelligent Risk, Fraud &amp; Financial Experiences.</a:t>
             </a:r>
           </a:p>
         </p:txBody>
@@ -7979,324 +7979,6 @@
           </a:p>
         </p:txBody>
       </p:sp>
-      <p:pic>
-        <p:nvPicPr>
-          <p:cNvPr id="59" name="Picture 58" descr="s02_54.png"/>
-          <p:cNvPicPr>
-            <a:picLocks noChangeAspect="1"/>
-          </p:cNvPicPr>
-          <p:nvPr/>
-        </p:nvPicPr>
-        <p:blipFill>
-          <a:blip r:embed="rId5"/>
-          <a:stretch>
-            <a:fillRect/>
-          </a:stretch>
-        </p:blipFill>
-        <p:spPr>
-          <a:xfrm>
-            <a:off x="6163055" y="3566160"/>
-            <a:ext cx="658368" cy="658368"/>
-          </a:xfrm>
-          <a:prstGeom prst="rect">
-            <a:avLst/>
-          </a:prstGeom>
-        </p:spPr>
-      </p:pic>
-      <p:sp>
-        <p:nvSpPr>
-          <p:cNvPr id="60" name="TextBox 59"/>
-          <p:cNvSpPr txBox="1"/>
-          <p:nvPr/>
-        </p:nvSpPr>
-        <p:spPr>
-          <a:xfrm>
-            <a:off x="5998464" y="4261104"/>
-            <a:ext cx="950976" cy="182880"/>
-          </a:xfrm>
-          <a:prstGeom prst="rect">
-            <a:avLst/>
-          </a:prstGeom>
-          <a:noFill/>
-        </p:spPr>
-        <p:txBody>
-          <a:bodyPr wrap="square" lIns="0" tIns="0" rIns="0" bIns="0" anchor="t">
-            <a:noAutofit/>
-          </a:bodyPr>
-          <a:lstStyle/>
-          <a:p>
-            <a:pPr algn="ctr">
-              <a:spcAft>
-                <a:spcPts val="200"/>
-              </a:spcAft>
-            </a:pPr>
-            <a:r>
-              <a:rPr sz="750" b="1" i="0">
-                <a:solidFill>
-                  <a:srgbClr val="202124"/>
-                </a:solidFill>
-                <a:latin typeface="Google Sans Flex"/>
-                <a:ea typeface="Google Sans Flex"/>
-                <a:cs typeface="Google Sans Flex"/>
-              </a:rPr>
-              <a:t>Thanveer Ahamed</a:t>
-            </a:r>
-          </a:p>
-        </p:txBody>
-      </p:sp>
-      <p:sp>
-        <p:nvSpPr>
-          <p:cNvPr id="61" name="TextBox 60"/>
-          <p:cNvSpPr txBox="1"/>
-          <p:nvPr/>
-        </p:nvSpPr>
-        <p:spPr>
-          <a:xfrm>
-            <a:off x="5998464" y="4425696"/>
-            <a:ext cx="950976" cy="292608"/>
-          </a:xfrm>
-          <a:prstGeom prst="rect">
-            <a:avLst/>
-          </a:prstGeom>
-          <a:noFill/>
-        </p:spPr>
-        <p:txBody>
-          <a:bodyPr wrap="square" lIns="0" tIns="0" rIns="0" bIns="0" anchor="t">
-            <a:noAutofit/>
-          </a:bodyPr>
-          <a:lstStyle/>
-          <a:p>
-            <a:pPr algn="ctr">
-              <a:spcAft>
-                <a:spcPts val="200"/>
-              </a:spcAft>
-            </a:pPr>
-            <a:r>
-              <a:rPr sz="650" b="0" i="0">
-                <a:solidFill>
-                  <a:srgbClr val="5F6368"/>
-                </a:solidFill>
-                <a:latin typeface="Google Sans Flex"/>
-                <a:ea typeface="Google Sans Flex"/>
-                <a:cs typeface="Google Sans Flex"/>
-              </a:rPr>
-              <a:t>Leader · Gen AI</a:t>
-            </a:r>
-          </a:p>
-        </p:txBody>
-      </p:sp>
-      <p:pic>
-        <p:nvPicPr>
-          <p:cNvPr id="62" name="Picture 61" descr="s02_60.png"/>
-          <p:cNvPicPr>
-            <a:picLocks noChangeAspect="1"/>
-          </p:cNvPicPr>
-          <p:nvPr/>
-        </p:nvPicPr>
-        <p:blipFill>
-          <a:blip r:embed="rId6"/>
-          <a:stretch>
-            <a:fillRect/>
-          </a:stretch>
-        </p:blipFill>
-        <p:spPr>
-          <a:xfrm>
-            <a:off x="7114031" y="3566160"/>
-            <a:ext cx="658368" cy="658368"/>
-          </a:xfrm>
-          <a:prstGeom prst="rect">
-            <a:avLst/>
-          </a:prstGeom>
-        </p:spPr>
-      </p:pic>
-      <p:sp>
-        <p:nvSpPr>
-          <p:cNvPr id="63" name="TextBox 62"/>
-          <p:cNvSpPr txBox="1"/>
-          <p:nvPr/>
-        </p:nvSpPr>
-        <p:spPr>
-          <a:xfrm>
-            <a:off x="6949440" y="4261104"/>
-            <a:ext cx="950976" cy="182880"/>
-          </a:xfrm>
-          <a:prstGeom prst="rect">
-            <a:avLst/>
-          </a:prstGeom>
-          <a:noFill/>
-        </p:spPr>
-        <p:txBody>
-          <a:bodyPr wrap="square" lIns="0" tIns="0" rIns="0" bIns="0" anchor="t">
-            <a:noAutofit/>
-          </a:bodyPr>
-          <a:lstStyle/>
-          <a:p>
-            <a:pPr algn="ctr">
-              <a:spcAft>
-                <a:spcPts val="200"/>
-              </a:spcAft>
-            </a:pPr>
-            <a:r>
-              <a:rPr sz="750" b="1" i="0">
-                <a:solidFill>
-                  <a:srgbClr val="202124"/>
-                </a:solidFill>
-                <a:latin typeface="Google Sans Flex"/>
-                <a:ea typeface="Google Sans Flex"/>
-                <a:cs typeface="Google Sans Flex"/>
-              </a:rPr>
-              <a:t>Janitha Prathapa</a:t>
-            </a:r>
-          </a:p>
-        </p:txBody>
-      </p:sp>
-      <p:sp>
-        <p:nvSpPr>
-          <p:cNvPr id="64" name="TextBox 63"/>
-          <p:cNvSpPr txBox="1"/>
-          <p:nvPr/>
-        </p:nvSpPr>
-        <p:spPr>
-          <a:xfrm>
-            <a:off x="6949440" y="4425696"/>
-            <a:ext cx="950976" cy="292608"/>
-          </a:xfrm>
-          <a:prstGeom prst="rect">
-            <a:avLst/>
-          </a:prstGeom>
-          <a:noFill/>
-        </p:spPr>
-        <p:txBody>
-          <a:bodyPr wrap="square" lIns="0" tIns="0" rIns="0" bIns="0" anchor="t">
-            <a:noAutofit/>
-          </a:bodyPr>
-          <a:lstStyle/>
-          <a:p>
-            <a:pPr algn="ctr">
-              <a:spcAft>
-                <a:spcPts val="200"/>
-              </a:spcAft>
-            </a:pPr>
-            <a:r>
-              <a:rPr sz="650" b="0" i="0">
-                <a:solidFill>
-                  <a:srgbClr val="5F6368"/>
-                </a:solidFill>
-                <a:latin typeface="Google Sans Flex"/>
-                <a:ea typeface="Google Sans Flex"/>
-                <a:cs typeface="Google Sans Flex"/>
-              </a:rPr>
-              <a:t>Vision AI Lead</a:t>
-            </a:r>
-          </a:p>
-        </p:txBody>
-      </p:sp>
-      <p:pic>
-        <p:nvPicPr>
-          <p:cNvPr id="65" name="Picture 64" descr="s02_66.png"/>
-          <p:cNvPicPr>
-            <a:picLocks noChangeAspect="1"/>
-          </p:cNvPicPr>
-          <p:nvPr/>
-        </p:nvPicPr>
-        <p:blipFill>
-          <a:blip r:embed="rId7"/>
-          <a:stretch>
-            <a:fillRect/>
-          </a:stretch>
-        </p:blipFill>
-        <p:spPr>
-          <a:xfrm>
-            <a:off x="8065008" y="3566160"/>
-            <a:ext cx="658368" cy="658368"/>
-          </a:xfrm>
-          <a:prstGeom prst="rect">
-            <a:avLst/>
-          </a:prstGeom>
-        </p:spPr>
-      </p:pic>
-      <p:sp>
-        <p:nvSpPr>
-          <p:cNvPr id="66" name="TextBox 65"/>
-          <p:cNvSpPr txBox="1"/>
-          <p:nvPr/>
-        </p:nvSpPr>
-        <p:spPr>
-          <a:xfrm>
-            <a:off x="7900416" y="4261104"/>
-            <a:ext cx="950976" cy="182880"/>
-          </a:xfrm>
-          <a:prstGeom prst="rect">
-            <a:avLst/>
-          </a:prstGeom>
-          <a:noFill/>
-        </p:spPr>
-        <p:txBody>
-          <a:bodyPr wrap="square" lIns="0" tIns="0" rIns="0" bIns="0" anchor="t">
-            <a:noAutofit/>
-          </a:bodyPr>
-          <a:lstStyle/>
-          <a:p>
-            <a:pPr algn="ctr">
-              <a:spcAft>
-                <a:spcPts val="200"/>
-              </a:spcAft>
-            </a:pPr>
-            <a:r>
-              <a:rPr sz="750" b="1" i="0">
-                <a:solidFill>
-                  <a:srgbClr val="202124"/>
-                </a:solidFill>
-                <a:latin typeface="Google Sans Flex"/>
-                <a:ea typeface="Google Sans Flex"/>
-                <a:cs typeface="Google Sans Flex"/>
-              </a:rPr>
-              <a:t>Dinal Fernando</a:t>
-            </a:r>
-          </a:p>
-        </p:txBody>
-      </p:sp>
-      <p:sp>
-        <p:nvSpPr>
-          <p:cNvPr id="67" name="TextBox 66"/>
-          <p:cNvSpPr txBox="1"/>
-          <p:nvPr/>
-        </p:nvSpPr>
-        <p:spPr>
-          <a:xfrm>
-            <a:off x="7900416" y="4425696"/>
-            <a:ext cx="950976" cy="292608"/>
-          </a:xfrm>
-          <a:prstGeom prst="rect">
-            <a:avLst/>
-          </a:prstGeom>
-          <a:noFill/>
-        </p:spPr>
-        <p:txBody>
-          <a:bodyPr wrap="square" lIns="0" tIns="0" rIns="0" bIns="0" anchor="t">
-            <a:noAutofit/>
-          </a:bodyPr>
-          <a:lstStyle/>
-          <a:p>
-            <a:pPr algn="ctr">
-              <a:spcAft>
-                <a:spcPts val="200"/>
-              </a:spcAft>
-            </a:pPr>
-            <a:r>
-              <a:rPr sz="650" b="0" i="0">
-                <a:solidFill>
-                  <a:srgbClr val="5F6368"/>
-                </a:solidFill>
-                <a:latin typeface="Google Sans Flex"/>
-                <a:ea typeface="Google Sans Flex"/>
-                <a:cs typeface="Google Sans Flex"/>
-              </a:rPr>
-              <a:t>Solution Architect</a:t>
-            </a:r>
-          </a:p>
-        </p:txBody>
-      </p:sp>
     </p:spTree>
   </p:cSld>
   <p:clrMapOvr>
@@ -13131,7 +12813,7 @@
                 <a:ea typeface="Google Sans Flex"/>
                 <a:cs typeface="Google Sans Flex"/>
               </a:rPr>
-              <a:t>Responsible AI, go-to-market and the team behind it</a:t>
+              <a:t>Responsible AI and the go-to-market plan</a:t>
             </a:r>
           </a:p>
         </p:txBody>
@@ -14790,7 +14472,7 @@
         </p:nvSpPr>
         <p:spPr>
           <a:xfrm>
-            <a:off x="347472" y="3840480"/>
+            <a:off x="347472" y="4114800"/>
             <a:ext cx="8449056" cy="457200"/>
           </a:xfrm>
           <a:prstGeom prst="roundRect">
@@ -14841,80 +14523,6 @@
                 <a:cs typeface="Google Sans Flex"/>
               </a:rPr>
               <a:t>“Every lender and insurer already asks for photos. We replace them with a short phone video that is trustworthy, explainable and ready for a decision.”</a:t>
-            </a:r>
-          </a:p>
-        </p:txBody>
-      </p:sp>
-      <p:sp>
-        <p:nvSpPr>
-          <p:cNvPr id="206" name="Rounded Rectangle 205"/>
-          <p:cNvSpPr/>
-          <p:nvPr/>
-        </p:nvSpPr>
-        <p:spPr>
-          <a:xfrm>
-            <a:off x="347472" y="4389120"/>
-            <a:ext cx="8449056" cy="502920"/>
-          </a:xfrm>
-          <a:prstGeom prst="roundRect">
-            <a:avLst>
-              <a:gd name="adj" fmla="val 10909"/>
-            </a:avLst>
-          </a:prstGeom>
-          <a:solidFill>
-            <a:srgbClr val="E8F0FE"/>
-          </a:solidFill>
-          <a:ln>
-            <a:noFill/>
-          </a:ln>
-          <a:effectLst/>
-        </p:spPr>
-        <p:style>
-          <a:lnRef idx="1">
-            <a:schemeClr val="accent1"/>
-          </a:lnRef>
-          <a:fillRef idx="3">
-            <a:schemeClr val="accent1"/>
-          </a:fillRef>
-          <a:effectRef idx="2">
-            <a:schemeClr val="accent1"/>
-          </a:effectRef>
-          <a:fontRef idx="minor">
-            <a:schemeClr val="lt1"/>
-          </a:fontRef>
-        </p:style>
-        <p:txBody>
-          <a:bodyPr wrap="square" tIns="73152" bIns="73152" rtlCol="0" anchor="ctr">
-            <a:noAutofit/>
-          </a:bodyPr>
-          <a:lstStyle/>
-          <a:p>
-            <a:pPr algn="l">
-              <a:spcAft>
-                <a:spcPts val="200"/>
-              </a:spcAft>
-            </a:pPr>
-            <a:r>
-              <a:rPr sz="700" b="1" i="0">
-                <a:solidFill>
-                  <a:srgbClr val="202124"/>
-                </a:solidFill>
-                <a:latin typeface="Google Sans Flex"/>
-                <a:ea typeface="Google Sans Flex"/>
-                <a:cs typeface="Google Sans Flex"/>
-              </a:rPr>
-              <a:t>Team Xcore: </a:t>
-            </a:r>
-            <a:r>
-              <a:rPr sz="700" b="0" i="0">
-                <a:solidFill>
-                  <a:srgbClr val="202124"/>
-                </a:solidFill>
-                <a:latin typeface="Google Sans Flex"/>
-                <a:ea typeface="Google Sans Flex"/>
-                <a:cs typeface="Google Sans Flex"/>
-              </a:rPr>
-              <a:t>Thanveer Ahamed (Team Leader, Gen AI: Gemini &amp; Gemma reasoning, verification, underwriting assistant) · Janitha Prathapa (Vision AI: defect detection, Depth Anything 3, SLAM, 3D, coverage map) · Dinal Fernando (Solution Architect: Cloud Run, Vertex AI, BigQuery, Pub/Sub, deployment)</a:t>
             </a:r>
           </a:p>
         </p:txBody>

</xml_diff>

<commit_message>
Restore team photos and names on the submission deck's Team Details slide (no role labels)
</commit_message>
<xml_diff>
--- a/docs/pitch-deck/Property_Inspection_AI_Submission_Xcore.pptx
+++ b/docs/pitch-deck/Property_Inspection_AI_Submission_Xcore.pptx
@@ -7979,6 +7979,201 @@
           </a:p>
         </p:txBody>
       </p:sp>
+      <p:pic>
+        <p:nvPicPr>
+          <p:cNvPr id="59" name="Picture 58" descr="s02_54.png"/>
+          <p:cNvPicPr>
+            <a:picLocks noChangeAspect="1"/>
+          </p:cNvPicPr>
+          <p:nvPr/>
+        </p:nvPicPr>
+        <p:blipFill>
+          <a:blip r:embed="rId5"/>
+          <a:stretch>
+            <a:fillRect/>
+          </a:stretch>
+        </p:blipFill>
+        <p:spPr>
+          <a:xfrm>
+            <a:off x="6163055" y="3566160"/>
+            <a:ext cx="658368" cy="658368"/>
+          </a:xfrm>
+          <a:prstGeom prst="rect">
+            <a:avLst/>
+          </a:prstGeom>
+        </p:spPr>
+      </p:pic>
+      <p:sp>
+        <p:nvSpPr>
+          <p:cNvPr id="60" name="TextBox 59"/>
+          <p:cNvSpPr txBox="1"/>
+          <p:nvPr/>
+        </p:nvSpPr>
+        <p:spPr>
+          <a:xfrm>
+            <a:off x="5998464" y="4261104"/>
+            <a:ext cx="950976" cy="182880"/>
+          </a:xfrm>
+          <a:prstGeom prst="rect">
+            <a:avLst/>
+          </a:prstGeom>
+          <a:noFill/>
+        </p:spPr>
+        <p:txBody>
+          <a:bodyPr wrap="square" lIns="0" tIns="0" rIns="0" bIns="0" anchor="t">
+            <a:noAutofit/>
+          </a:bodyPr>
+          <a:lstStyle/>
+          <a:p>
+            <a:pPr algn="ctr">
+              <a:spcAft>
+                <a:spcPts val="200"/>
+              </a:spcAft>
+            </a:pPr>
+            <a:r>
+              <a:rPr sz="750" b="1" i="0">
+                <a:solidFill>
+                  <a:srgbClr val="202124"/>
+                </a:solidFill>
+                <a:latin typeface="Google Sans Flex"/>
+                <a:ea typeface="Google Sans Flex"/>
+                <a:cs typeface="Google Sans Flex"/>
+              </a:rPr>
+              <a:t>Thanveer Ahamed</a:t>
+            </a:r>
+          </a:p>
+        </p:txBody>
+      </p:sp>
+      <p:pic>
+        <p:nvPicPr>
+          <p:cNvPr id="61" name="Picture 61" descr="s02_60.png"/>
+          <p:cNvPicPr>
+            <a:picLocks noChangeAspect="1"/>
+          </p:cNvPicPr>
+          <p:nvPr/>
+        </p:nvPicPr>
+        <p:blipFill>
+          <a:blip r:embed="rId6"/>
+          <a:stretch>
+            <a:fillRect/>
+          </a:stretch>
+        </p:blipFill>
+        <p:spPr>
+          <a:xfrm>
+            <a:off x="7114031" y="3566160"/>
+            <a:ext cx="658368" cy="658368"/>
+          </a:xfrm>
+          <a:prstGeom prst="rect">
+            <a:avLst/>
+          </a:prstGeom>
+        </p:spPr>
+      </p:pic>
+      <p:sp>
+        <p:nvSpPr>
+          <p:cNvPr id="62" name="TextBox 62"/>
+          <p:cNvSpPr txBox="1"/>
+          <p:nvPr/>
+        </p:nvSpPr>
+        <p:spPr>
+          <a:xfrm>
+            <a:off x="6949440" y="4261104"/>
+            <a:ext cx="950976" cy="182880"/>
+          </a:xfrm>
+          <a:prstGeom prst="rect">
+            <a:avLst/>
+          </a:prstGeom>
+          <a:noFill/>
+        </p:spPr>
+        <p:txBody>
+          <a:bodyPr wrap="square" lIns="0" tIns="0" rIns="0" bIns="0" anchor="t">
+            <a:noAutofit/>
+          </a:bodyPr>
+          <a:lstStyle/>
+          <a:p>
+            <a:pPr algn="ctr">
+              <a:spcAft>
+                <a:spcPts val="200"/>
+              </a:spcAft>
+            </a:pPr>
+            <a:r>
+              <a:rPr sz="750" b="1" i="0">
+                <a:solidFill>
+                  <a:srgbClr val="202124"/>
+                </a:solidFill>
+                <a:latin typeface="Google Sans Flex"/>
+                <a:ea typeface="Google Sans Flex"/>
+                <a:cs typeface="Google Sans Flex"/>
+              </a:rPr>
+              <a:t>Janitha Prathapa</a:t>
+            </a:r>
+          </a:p>
+        </p:txBody>
+      </p:sp>
+      <p:pic>
+        <p:nvPicPr>
+          <p:cNvPr id="63" name="Picture 64" descr="s02_66.png"/>
+          <p:cNvPicPr>
+            <a:picLocks noChangeAspect="1"/>
+          </p:cNvPicPr>
+          <p:nvPr/>
+        </p:nvPicPr>
+        <p:blipFill>
+          <a:blip r:embed="rId7"/>
+          <a:stretch>
+            <a:fillRect/>
+          </a:stretch>
+        </p:blipFill>
+        <p:spPr>
+          <a:xfrm>
+            <a:off x="8065008" y="3566160"/>
+            <a:ext cx="658368" cy="658368"/>
+          </a:xfrm>
+          <a:prstGeom prst="rect">
+            <a:avLst/>
+          </a:prstGeom>
+        </p:spPr>
+      </p:pic>
+      <p:sp>
+        <p:nvSpPr>
+          <p:cNvPr id="64" name="TextBox 65"/>
+          <p:cNvSpPr txBox="1"/>
+          <p:nvPr/>
+        </p:nvSpPr>
+        <p:spPr>
+          <a:xfrm>
+            <a:off x="7900416" y="4261104"/>
+            <a:ext cx="950976" cy="182880"/>
+          </a:xfrm>
+          <a:prstGeom prst="rect">
+            <a:avLst/>
+          </a:prstGeom>
+          <a:noFill/>
+        </p:spPr>
+        <p:txBody>
+          <a:bodyPr wrap="square" lIns="0" tIns="0" rIns="0" bIns="0" anchor="t">
+            <a:noAutofit/>
+          </a:bodyPr>
+          <a:lstStyle/>
+          <a:p>
+            <a:pPr algn="ctr">
+              <a:spcAft>
+                <a:spcPts val="200"/>
+              </a:spcAft>
+            </a:pPr>
+            <a:r>
+              <a:rPr sz="750" b="1" i="0">
+                <a:solidFill>
+                  <a:srgbClr val="202124"/>
+                </a:solidFill>
+                <a:latin typeface="Google Sans Flex"/>
+                <a:ea typeface="Google Sans Flex"/>
+                <a:cs typeface="Google Sans Flex"/>
+              </a:rPr>
+              <a:t>Dinal Fernando</a:t>
+            </a:r>
+          </a:p>
+        </p:txBody>
+      </p:sp>
     </p:spTree>
   </p:cSld>
   <p:clrMapOvr>

</xml_diff>

<commit_message>
Submission deck roadmap: next an inspection agent (Gemini on Agent Platform: live capture guidance, spatial reasoning over the 3D model, answers per stakeholder), later agent hand-offs to core systems; PDF regenerated from the same file (includes team photos)
</commit_message>
<xml_diff>
--- a/docs/pitch-deck/Property_Inspection_AI_Submission_Xcore.pptx
+++ b/docs/pitch-deck/Property_Inspection_AI_Submission_Xcore.pptx
@@ -10862,7 +10862,7 @@
                 <a:ea typeface="Google Sans Flex"/>
                 <a:cs typeface="Google Sans Flex"/>
               </a:rPr>
-              <a:t>Roadmap: documents, policies and predictive portfolio risk</a:t>
+              <a:t>Roadmap: an inspection agent with spatial reasoning, then portfolio risk</a:t>
             </a:r>
           </a:p>
         </p:txBody>
@@ -11256,7 +11256,7 @@
                 <a:ea typeface="Google Sans Flex"/>
                 <a:cs typeface="Google Sans Flex"/>
               </a:rPr>
-              <a:t>Mobile guided capture with live coverage</a:t>
+              <a:t>Inspection agent: Gemini + Agent Platform (ADK)</a:t>
             </a:r>
           </a:p>
           <a:p>
@@ -11279,7 +11279,7 @@
                 <a:ea typeface="Google Sans Flex"/>
                 <a:cs typeface="Google Sans Flex"/>
               </a:rPr>
-              <a:t>Document AI: deeds, valuations, invoices</a:t>
+              <a:t>Live capture guidance: what to film next</a:t>
             </a:r>
           </a:p>
           <a:p>
@@ -11302,7 +11302,7 @@
                 <a:ea typeface="Google Sans Flex"/>
                 <a:cs typeface="Google Sans Flex"/>
               </a:rPr>
-              <a:t>Vertex AI Search over policy wording</a:t>
+              <a:t>Spatial reasoning over the 3D model</a:t>
             </a:r>
           </a:p>
           <a:p>
@@ -11325,7 +11325,7 @@
                 <a:ea typeface="Google Sans Flex"/>
                 <a:cs typeface="Google Sans Flex"/>
               </a:rPr>
-              <a:t>Commercial localiser (Gemini / Vertex-tuned)</a:t>
+              <a:t>Answers for lender, insurer, surveyor, owner</a:t>
             </a:r>
           </a:p>
         </p:txBody>
@@ -11540,7 +11540,7 @@
                 <a:ea typeface="Google Sans Flex"/>
                 <a:cs typeface="Google Sans Flex"/>
               </a:rPr>
-              <a:t>Multilingual reports (Gemini)</a:t>
+              <a:t>Document AI + Vertex AI Search: deeds, policies</a:t>
             </a:r>
           </a:p>
           <a:p>
@@ -11563,7 +11563,7 @@
                 <a:ea typeface="Google Sans Flex"/>
                 <a:cs typeface="Google Sans Flex"/>
               </a:rPr>
-              <a:t>AlloyDB multi-tenant case management</a:t>
+              <a:t>Agent hand-offs to core systems, human approval</a:t>
             </a:r>
           </a:p>
         </p:txBody>

</xml_diff>

<commit_message>
Submission deck: add the demo video link on the Links slide and make the video, GitHub and live-app links clickable; PDF regenerated from the same file
</commit_message>
<xml_diff>
--- a/docs/pitch-deck/Property_Inspection_AI_Submission_Xcore.pptx
+++ b/docs/pitch-deck/Property_Inspection_AI_Submission_Xcore.pptx
@@ -14938,6 +14938,7 @@
                 <a:latin typeface="Google Sans Flex"/>
                 <a:ea typeface="Google Sans Flex"/>
                 <a:cs typeface="Google Sans Flex"/>
+                <a:hlinkClick r:id="rId5"/>
               </a:rPr>
               <a:t>github.com/XCore-Lab/property-inspection-ai</a:t>
             </a:r>
@@ -14972,13 +14973,14 @@
             <a:r>
               <a:rPr sz="1300" b="1" i="0">
                 <a:solidFill>
-                  <a:srgbClr val="D93025"/>
-                </a:solidFill>
-                <a:latin typeface="Google Sans Flex"/>
-                <a:ea typeface="Google Sans Flex"/>
-                <a:cs typeface="Google Sans Flex"/>
-              </a:rPr>
-              <a:t>[paste link here]</a:t>
+                  <a:srgbClr val="1A73E8"/>
+                </a:solidFill>
+                <a:latin typeface="Google Sans Flex"/>
+                <a:ea typeface="Google Sans Flex"/>
+                <a:cs typeface="Google Sans Flex"/>
+                <a:hlinkClick r:id="rId6"/>
+              </a:rPr>
+              <a:t>drive.google.com/file/d/1C8Ysukjfhx-oKpXUv56eheGLf7wP9lb9/view</a:t>
             </a:r>
             <a:endParaRPr>
               <a:latin typeface="Google Sans Flex Medium"/>
@@ -15016,6 +15018,7 @@
                 <a:latin typeface="Google Sans Flex"/>
                 <a:ea typeface="Google Sans Flex"/>
                 <a:cs typeface="Google Sans Flex"/>
+                <a:hlinkClick r:id="rId7"/>
               </a:rPr>
               <a:t>property-inspection-ai-77055350047.us-central1.run.app</a:t>
             </a:r>
@@ -15054,7 +15057,7 @@
           <p:nvPr/>
         </p:nvPicPr>
         <p:blipFill>
-          <a:blip r:embed="rId5"/>
+          <a:blip r:embed="rId8"/>
           <a:stretch>
             <a:fillRect/>
           </a:stretch>

</xml_diff>